<commit_message>
Rewrite client architecture copy as statements, not meeting recap.
Removes phrases such as “Emeraid asked” and “already discussed” so the pack reads as a proposed design, not internal notes.

Co-authored-by: Eyuren Hanson <hansoneyuren@gmail.com>
</commit_message>
<xml_diff>
--- a/edfip-screening/architecture/EDFIP_Architecture_Dexta.pptx
+++ b/edfip-screening/architecture/EDFIP_Architecture_Dexta.pptx
@@ -3246,7 +3246,7 @@
                 </a:solidFill>
                 <a:latin typeface="Calibri"/>
               </a:rPr>
-              <a:t>This walkthrough develops the Apache Fineract and Odoo architecture already shared. It shows how EDFIP operates as multi-tenant software-as-a-service that Emeraid will brand and sell.</a:t>
+              <a:t>This document sets out how EDFIP operates as multi-tenant software-as-a-service that Emeraid will host, brand, and sell.</a:t>
             </a:r>
           </a:p>
         </p:txBody>
@@ -4342,7 +4342,7 @@
                 </a:solidFill>
                 <a:latin typeface="Calibri"/>
               </a:rPr>
-              <a:t>PROPOSAL</a:t>
+              <a:t>FOUNDATION</a:t>
             </a:r>
           </a:p>
         </p:txBody>
@@ -4377,8 +4377,8 @@
                 </a:solidFill>
                 <a:latin typeface="Georgia"/>
               </a:rPr>
-              <a:t>This develops the architecture
-already discussed.</a:t>
+              <a:t>Odoo remains the operating platform.
+Fineract provides core banking.</a:t>
             </a:r>
           </a:p>
         </p:txBody>
@@ -4483,8 +4483,8 @@
                 </a:solidFill>
                 <a:latin typeface="Calibri"/>
               </a:rPr>
-              <a:t>The 13 August 2026 financial proposal used an Odoo-only foundation for core banking. Using Apache Fineract keeps Odoo as the operating platform and avoids building that engine from scratch.
-It changes delivery composition. Effort and commercial terms for the combined stack will be confirmed with Emeraid under change control.</a:t>
+              <a:t>The 13 August 2026 financial proposal assumed an Odoo-only foundation for core banking. This architecture uses Apache Fineract for core banking so that Odoo remains the operating platform, rather than building that engine from scratch.
+The combined stack changes delivery composition. Effort and commercial terms will be confirmed under the engagement’s change-control process.</a:t>
             </a:r>
           </a:p>
         </p:txBody>

</xml_diff>

<commit_message>
Describe institution customers in client language: record, branch, officer, accounts.
Adds how a member of an MFI is opened on the operating platform, mirrored in core banking, and shown only their own accounts on the customer app.

Co-authored-by: Eyuren Hanson <hansoneyuren@gmail.com>
</commit_message>
<xml_diff>
--- a/edfip-screening/architecture/EDFIP_Architecture_Dexta.pptx
+++ b/edfip-screening/architecture/EDFIP_Architecture_Dexta.pptx
@@ -19,6 +19,8 @@
     <p:sldId id="267" r:id="rId18"/>
     <p:sldId id="268" r:id="rId19"/>
     <p:sldId id="269" r:id="rId20"/>
+    <p:sldId id="270" r:id="rId21"/>
+    <p:sldId id="271" r:id="rId22"/>
   </p:sldIdLst>
   <p:sldSz cx="12191695" cy="6858000" type="screen4x3"/>
   <p:notesSz cx="6858000" cy="9144000"/>
@@ -3316,7 +3318,7 @@
                 </a:solidFill>
                 <a:latin typeface="Calibri"/>
               </a:rPr>
-              <a:t>01 / 14</a:t>
+              <a:t>01 / 16</a:t>
             </a:r>
           </a:p>
         </p:txBody>
@@ -3412,7 +3414,7 @@
                 </a:solidFill>
                 <a:latin typeface="Calibri"/>
               </a:rPr>
-              <a:t>OWNERSHIP</a:t>
+              <a:t>CUSTOMERS</a:t>
             </a:r>
           </a:p>
         </p:txBody>
@@ -3447,8 +3449,8 @@
                 </a:solidFill>
                 <a:latin typeface="Georgia"/>
               </a:rPr>
-              <a:t>Each domain has one
-system of record.</a:t>
+              <a:t>The record and the accounts are linked.
+They are not two people.</a:t>
             </a:r>
           </a:p>
         </p:txBody>
@@ -3518,7 +3520,7 @@
                 </a:solidFill>
                 <a:latin typeface="Calibri"/>
               </a:rPr>
-              <a:t>10 / 14</a:t>
+              <a:t>10 / 16</a:t>
             </a:r>
           </a:p>
         </p:txBody>
@@ -3531,31 +3533,101 @@
         </p:nvSpPr>
         <p:spPr>
           <a:xfrm>
-            <a:off x="640080" y="2331720"/>
-            <a:ext cx="10972800" cy="3474720"/>
-          </a:xfrm>
-          <a:prstGeom prst="rect">
-            <a:avLst/>
-          </a:prstGeom>
-          <a:noFill/>
-        </p:spPr>
-        <p:txBody>
-          <a:bodyPr wrap="square">
-            <a:spAutoFit/>
-          </a:bodyPr>
-          <a:lstStyle/>
-          <a:p>
-            <a:pPr algn="l"/>
-            <a:r>
-              <a:rPr sz="1800" b="0">
+            <a:off x="640080" y="2468880"/>
+            <a:ext cx="5303520" cy="3108960"/>
+          </a:xfrm>
+          <a:prstGeom prst="rect">
+            <a:avLst/>
+          </a:prstGeom>
+          <a:noFill/>
+        </p:spPr>
+        <p:txBody>
+          <a:bodyPr wrap="square">
+            <a:spAutoFit/>
+          </a:bodyPr>
+          <a:lstStyle/>
+          <a:p>
+            <a:pPr algn="l"/>
+            <a:r>
+              <a:rPr sz="1600" b="0">
                 <a:solidFill>
                   <a:srgbClr val="F4F0E6"/>
                 </a:solidFill>
                 <a:latin typeface="Calibri"/>
               </a:rPr>
-              <a:t>Odoo masters  —  tenant, licence, packs, CRM, KYC, VSLA ceremony, PayGo devices, agency operations.
-Fineract masters  —  loans, savings, balances, general ledger.
-FastAPI  —  mobile, USSD, payments, and OEM calls, posting money in Fineract.</a:t>
+              <a:t>OPERATING PLATFORM
+Name, KYC, documents, CRM, home branch, account officer. What staff use every day.</a:t>
+            </a:r>
+          </a:p>
+        </p:txBody>
+      </p:sp>
+      <p:sp>
+        <p:nvSpPr>
+          <p:cNvPr id="8" name="TextBox 7"/>
+          <p:cNvSpPr txBox="1"/>
+          <p:nvPr/>
+        </p:nvSpPr>
+        <p:spPr>
+          <a:xfrm>
+            <a:off x="6400800" y="2468880"/>
+            <a:ext cx="5120640" cy="3108960"/>
+          </a:xfrm>
+          <a:prstGeom prst="rect">
+            <a:avLst/>
+          </a:prstGeom>
+          <a:noFill/>
+        </p:spPr>
+        <p:txBody>
+          <a:bodyPr wrap="square">
+            <a:spAutoFit/>
+          </a:bodyPr>
+          <a:lstStyle/>
+          <a:p>
+            <a:pPr algn="l"/>
+            <a:r>
+              <a:rPr sz="1600" b="0">
+                <a:solidFill>
+                  <a:srgbClr val="F4F0E6"/>
+                </a:solidFill>
+                <a:latin typeface="Calibri"/>
+              </a:rPr>
+              <a:t>CORE BANKING
+Savings and loan accounts, balances, repayment schedule, ledger. The money.</a:t>
+            </a:r>
+          </a:p>
+        </p:txBody>
+      </p:sp>
+      <p:sp>
+        <p:nvSpPr>
+          <p:cNvPr id="9" name="TextBox 8"/>
+          <p:cNvSpPr txBox="1"/>
+          <p:nvPr/>
+        </p:nvSpPr>
+        <p:spPr>
+          <a:xfrm>
+            <a:off x="640080" y="5120640"/>
+            <a:ext cx="10972800" cy="1005840"/>
+          </a:xfrm>
+          <a:prstGeom prst="rect">
+            <a:avLst/>
+          </a:prstGeom>
+          <a:noFill/>
+        </p:spPr>
+        <p:txBody>
+          <a:bodyPr wrap="square">
+            <a:spAutoFit/>
+          </a:bodyPr>
+          <a:lstStyle/>
+          <a:p>
+            <a:pPr algn="l"/>
+            <a:r>
+              <a:rPr sz="1600" b="0">
+                <a:solidFill>
+                  <a:srgbClr val="A8B3AA"/>
+                </a:solidFill>
+                <a:latin typeface="Calibri"/>
+              </a:rPr>
+              <a:t>One customer number on both sides. The officer sees their portfolio. The customer sees only themselves.</a:t>
             </a:r>
           </a:p>
         </p:txBody>
@@ -3651,7 +3723,7 @@
                 </a:solidFill>
                 <a:latin typeface="Calibri"/>
               </a:rPr>
-              <a:t>SECURITY</a:t>
+              <a:t>CONTROL PLANE</a:t>
             </a:r>
           </a:p>
         </p:txBody>
@@ -3686,8 +3758,8 @@
                 </a:solidFill>
                 <a:latin typeface="Georgia"/>
               </a:rPr>
-              <a:t>Controls sit on every path,
-not only the server.</a:t>
+              <a:t>System Administration is how
+Emeraid operates the SaaS.</a:t>
             </a:r>
           </a:p>
         </p:txBody>
@@ -3757,7 +3829,7 @@
                 </a:solidFill>
                 <a:latin typeface="Calibri"/>
               </a:rPr>
-              <a:t>11 / 14</a:t>
+              <a:t>11 / 16</a:t>
             </a:r>
           </a:p>
         </p:txBody>
@@ -3770,30 +3842,30 @@
         </p:nvSpPr>
         <p:spPr>
           <a:xfrm>
-            <a:off x="640080" y="2377440"/>
-            <a:ext cx="3474720" cy="3200400"/>
-          </a:xfrm>
-          <a:prstGeom prst="rect">
-            <a:avLst/>
-          </a:prstGeom>
-          <a:noFill/>
-        </p:spPr>
-        <p:txBody>
-          <a:bodyPr wrap="square">
-            <a:spAutoFit/>
-          </a:bodyPr>
-          <a:lstStyle/>
-          <a:p>
-            <a:pPr algn="l"/>
-            <a:r>
-              <a:rPr sz="1500" b="0">
+            <a:off x="640080" y="2468880"/>
+            <a:ext cx="5303520" cy="2926080"/>
+          </a:xfrm>
+          <a:prstGeom prst="rect">
+            <a:avLst/>
+          </a:prstGeom>
+          <a:noFill/>
+        </p:spPr>
+        <p:txBody>
+          <a:bodyPr wrap="square">
+            <a:spAutoFit/>
+          </a:bodyPr>
+          <a:lstStyle/>
+          <a:p>
+            <a:pPr algn="l"/>
+            <a:r>
+              <a:rPr sz="1600" b="0">
                 <a:solidFill>
                   <a:srgbClr val="F4F0E6"/>
                 </a:solidFill>
                 <a:latin typeface="Calibri"/>
               </a:rPr>
-              <a:t>ACCESS
-TLS, OpenID Connect, multi-factor authentication, tenant and branch scope, licence enforcement on the API.</a:t>
+              <a:t>EMERAID SUPER ADMINISTRATOR
+Institutions, licences, packs, platform connectors, preparing core banking. Multi-factor authentication and a full audit trail.</a:t>
             </a:r>
           </a:p>
         </p:txBody>
@@ -3806,66 +3878,30 @@
         </p:nvSpPr>
         <p:spPr>
           <a:xfrm>
-            <a:off x="4389120" y="2377440"/>
-            <a:ext cx="3474720" cy="3200400"/>
-          </a:xfrm>
-          <a:prstGeom prst="rect">
-            <a:avLst/>
-          </a:prstGeom>
-          <a:noFill/>
-        </p:spPr>
-        <p:txBody>
-          <a:bodyPr wrap="square">
-            <a:spAutoFit/>
-          </a:bodyPr>
-          <a:lstStyle/>
-          <a:p>
-            <a:pPr algn="l"/>
-            <a:r>
-              <a:rPr sz="1500" b="0">
+            <a:off x="6400800" y="2468880"/>
+            <a:ext cx="5120640" cy="2926080"/>
+          </a:xfrm>
+          <a:prstGeom prst="rect">
+            <a:avLst/>
+          </a:prstGeom>
+          <a:noFill/>
+        </p:spPr>
+        <p:txBody>
+          <a:bodyPr wrap="square">
+            <a:spAutoFit/>
+          </a:bodyPr>
+          <a:lstStyle/>
+          <a:p>
+            <a:pPr algn="l"/>
+            <a:r>
+              <a:rPr sz="1600" b="0">
                 <a:solidFill>
                   <a:srgbClr val="F4F0E6"/>
                 </a:solidFill>
                 <a:latin typeface="Calibri"/>
               </a:rPr>
-              <a:t>MONEY
-Fineract is the only ledger. Idempotent posting. Maker-checker. Fineract is not a public staff site.</a:t>
-            </a:r>
-          </a:p>
-        </p:txBody>
-      </p:sp>
-      <p:sp>
-        <p:nvSpPr>
-          <p:cNvPr id="9" name="TextBox 8"/>
-          <p:cNvSpPr txBox="1"/>
-          <p:nvPr/>
-        </p:nvSpPr>
-        <p:spPr>
-          <a:xfrm>
-            <a:off x="8138160" y="2377440"/>
-            <a:ext cx="3474720" cy="3200400"/>
-          </a:xfrm>
-          <a:prstGeom prst="rect">
-            <a:avLst/>
-          </a:prstGeom>
-          <a:noFill/>
-        </p:spPr>
-        <p:txBody>
-          <a:bodyPr wrap="square">
-            <a:spAutoFit/>
-          </a:bodyPr>
-          <a:lstStyle/>
-          <a:p>
-            <a:pPr algn="l"/>
-            <a:r>
-              <a:rPr sz="1500" b="0">
-                <a:solidFill>
-                  <a:srgbClr val="F4F0E6"/>
-                </a:solidFill>
-                <a:latin typeface="Calibri"/>
-              </a:rPr>
-              <a:t>OPERATIONS
-Encryption, NDPR, encrypted field store, audit, backup and restore, software bill of materials, penetration testing.</a:t>
+              <a:t>INSTITUTION ADMINISTRATOR
+Their branches, staff, and local branding. They cannot see another institution or Emeraid’s platform credentials.</a:t>
             </a:r>
           </a:p>
         </p:txBody>
@@ -3961,7 +3997,7 @@
                 </a:solidFill>
                 <a:latin typeface="Calibri"/>
               </a:rPr>
-              <a:t>SAME ENVIRONMENT</a:t>
+              <a:t>OWNERSHIP</a:t>
             </a:r>
           </a:p>
         </p:txBody>
@@ -3996,8 +4032,8 @@
                 </a:solidFill>
                 <a:latin typeface="Georgia"/>
               </a:rPr>
-              <a:t>Odoo and FastAPI are neighbours,
-not one programme.</a:t>
+              <a:t>Each domain has one
+system of record.</a:t>
             </a:r>
           </a:p>
         </p:txBody>
@@ -4067,7 +4103,7 @@
                 </a:solidFill>
                 <a:latin typeface="Calibri"/>
               </a:rPr>
-              <a:t>12 / 14</a:t>
+              <a:t>12 / 16</a:t>
             </a:r>
           </a:p>
         </p:txBody>
@@ -4081,172 +4117,30 @@
         <p:spPr>
           <a:xfrm>
             <a:off x="640080" y="2331720"/>
-            <a:ext cx="2560320" cy="2926080"/>
-          </a:xfrm>
-          <a:prstGeom prst="rect">
-            <a:avLst/>
-          </a:prstGeom>
-          <a:noFill/>
-        </p:spPr>
-        <p:txBody>
-          <a:bodyPr wrap="square">
-            <a:spAutoFit/>
-          </a:bodyPr>
-          <a:lstStyle/>
-          <a:p>
-            <a:pPr algn="l"/>
-            <a:r>
-              <a:rPr sz="1500" b="0">
+            <a:ext cx="10972800" cy="3474720"/>
+          </a:xfrm>
+          <a:prstGeom prst="rect">
+            <a:avLst/>
+          </a:prstGeom>
+          <a:noFill/>
+        </p:spPr>
+        <p:txBody>
+          <a:bodyPr wrap="square">
+            <a:spAutoFit/>
+          </a:bodyPr>
+          <a:lstStyle/>
+          <a:p>
+            <a:pPr algn="l"/>
+            <a:r>
+              <a:rPr sz="1800" b="0">
                 <a:solidFill>
                   <a:srgbClr val="F4F0E6"/>
                 </a:solidFill>
                 <a:latin typeface="Calibri"/>
               </a:rPr>
-              <a:t>NGINX
-TLS at the edge</a:t>
-            </a:r>
-          </a:p>
-        </p:txBody>
-      </p:sp>
-      <p:sp>
-        <p:nvSpPr>
-          <p:cNvPr id="8" name="TextBox 7"/>
-          <p:cNvSpPr txBox="1"/>
-          <p:nvPr/>
-        </p:nvSpPr>
-        <p:spPr>
-          <a:xfrm>
-            <a:off x="3383280" y="2331720"/>
-            <a:ext cx="2560320" cy="2926080"/>
-          </a:xfrm>
-          <a:prstGeom prst="rect">
-            <a:avLst/>
-          </a:prstGeom>
-          <a:noFill/>
-        </p:spPr>
-        <p:txBody>
-          <a:bodyPr wrap="square">
-            <a:spAutoFit/>
-          </a:bodyPr>
-          <a:lstStyle/>
-          <a:p>
-            <a:pPr algn="l"/>
-            <a:r>
-              <a:rPr sz="1500" b="0">
-                <a:solidFill>
-                  <a:srgbClr val="F4F0E6"/>
-                </a:solidFill>
-                <a:latin typeface="Calibri"/>
-              </a:rPr>
-              <a:t>/  →  ODOO
-Staff and System Administration</a:t>
-            </a:r>
-          </a:p>
-        </p:txBody>
-      </p:sp>
-      <p:sp>
-        <p:nvSpPr>
-          <p:cNvPr id="9" name="TextBox 8"/>
-          <p:cNvSpPr txBox="1"/>
-          <p:nvPr/>
-        </p:nvSpPr>
-        <p:spPr>
-          <a:xfrm>
-            <a:off x="6126480" y="2331720"/>
-            <a:ext cx="2560320" cy="2926080"/>
-          </a:xfrm>
-          <a:prstGeom prst="rect">
-            <a:avLst/>
-          </a:prstGeom>
-          <a:noFill/>
-        </p:spPr>
-        <p:txBody>
-          <a:bodyPr wrap="square">
-            <a:spAutoFit/>
-          </a:bodyPr>
-          <a:lstStyle/>
-          <a:p>
-            <a:pPr algn="l"/>
-            <a:r>
-              <a:rPr sz="1500" b="0">
-                <a:solidFill>
-                  <a:srgbClr val="F4F0E6"/>
-                </a:solidFill>
-                <a:latin typeface="Calibri"/>
-              </a:rPr>
-              <a:t>/API  →  FASTAPI
-Apps, USSD, partners</a:t>
-            </a:r>
-          </a:p>
-        </p:txBody>
-      </p:sp>
-      <p:sp>
-        <p:nvSpPr>
-          <p:cNvPr id="10" name="TextBox 9"/>
-          <p:cNvSpPr txBox="1"/>
-          <p:nvPr/>
-        </p:nvSpPr>
-        <p:spPr>
-          <a:xfrm>
-            <a:off x="8869680" y="2331720"/>
-            <a:ext cx="2651760" cy="2926080"/>
-          </a:xfrm>
-          <a:prstGeom prst="rect">
-            <a:avLst/>
-          </a:prstGeom>
-          <a:noFill/>
-        </p:spPr>
-        <p:txBody>
-          <a:bodyPr wrap="square">
-            <a:spAutoFit/>
-          </a:bodyPr>
-          <a:lstStyle/>
-          <a:p>
-            <a:pPr algn="l"/>
-            <a:r>
-              <a:rPr sz="1500" b="0">
-                <a:solidFill>
-                  <a:srgbClr val="F4F0E6"/>
-                </a:solidFill>
-                <a:latin typeface="Calibri"/>
-              </a:rPr>
-              <a:t>FINERACT
-Internal core banking only</a:t>
-            </a:r>
-          </a:p>
-        </p:txBody>
-      </p:sp>
-      <p:sp>
-        <p:nvSpPr>
-          <p:cNvPr id="11" name="TextBox 10"/>
-          <p:cNvSpPr txBox="1"/>
-          <p:nvPr/>
-        </p:nvSpPr>
-        <p:spPr>
-          <a:xfrm>
-            <a:off x="640080" y="5212080"/>
-            <a:ext cx="10972800" cy="914400"/>
-          </a:xfrm>
-          <a:prstGeom prst="rect">
-            <a:avLst/>
-          </a:prstGeom>
-          <a:noFill/>
-        </p:spPr>
-        <p:txBody>
-          <a:bodyPr wrap="square">
-            <a:spAutoFit/>
-          </a:bodyPr>
-          <a:lstStyle/>
-          <a:p>
-            <a:pPr algn="l"/>
-            <a:r>
-              <a:rPr sz="1600" b="0">
-                <a:solidFill>
-                  <a:srgbClr val="A8B3AA"/>
-                </a:solidFill>
-                <a:latin typeface="Calibri"/>
-              </a:rPr>
-              <a:t>Each component keeps its own database. They integrate through APIs.</a:t>
+              <a:t>Operating platform  —  institution, licence, packs, CRM, KYC, customer record, branch, account officer, VSLA, PayGo, agency.
+Core banking  —  savings and loan accounts, balances, general ledger.
+Integration service  —  field app, customer app, USSD, payments, and OEM calls, posting money in core banking.</a:t>
             </a:r>
           </a:p>
         </p:txBody>
@@ -4342,7 +4236,7 @@
                 </a:solidFill>
                 <a:latin typeface="Calibri"/>
               </a:rPr>
-              <a:t>FOUNDATION</a:t>
+              <a:t>SECURITY</a:t>
             </a:r>
           </a:p>
         </p:txBody>
@@ -4377,8 +4271,8 @@
                 </a:solidFill>
                 <a:latin typeface="Georgia"/>
               </a:rPr>
-              <a:t>Odoo remains the operating platform.
-Fineract provides core banking.</a:t>
+              <a:t>Controls sit on every path,
+not only the server.</a:t>
             </a:r>
           </a:p>
         </p:txBody>
@@ -4448,7 +4342,7 @@
                 </a:solidFill>
                 <a:latin typeface="Calibri"/>
               </a:rPr>
-              <a:t>13 / 14</a:t>
+              <a:t>13 / 16</a:t>
             </a:r>
           </a:p>
         </p:txBody>
@@ -4462,29 +4356,101 @@
         <p:spPr>
           <a:xfrm>
             <a:off x="640080" y="2377440"/>
-            <a:ext cx="10972800" cy="3291840"/>
-          </a:xfrm>
-          <a:prstGeom prst="rect">
-            <a:avLst/>
-          </a:prstGeom>
-          <a:noFill/>
-        </p:spPr>
-        <p:txBody>
-          <a:bodyPr wrap="square">
-            <a:spAutoFit/>
-          </a:bodyPr>
-          <a:lstStyle/>
-          <a:p>
-            <a:pPr algn="l"/>
-            <a:r>
-              <a:rPr sz="1800" b="0">
+            <a:ext cx="3474720" cy="3200400"/>
+          </a:xfrm>
+          <a:prstGeom prst="rect">
+            <a:avLst/>
+          </a:prstGeom>
+          <a:noFill/>
+        </p:spPr>
+        <p:txBody>
+          <a:bodyPr wrap="square">
+            <a:spAutoFit/>
+          </a:bodyPr>
+          <a:lstStyle/>
+          <a:p>
+            <a:pPr algn="l"/>
+            <a:r>
+              <a:rPr sz="1500" b="0">
                 <a:solidFill>
                   <a:srgbClr val="F4F0E6"/>
                 </a:solidFill>
                 <a:latin typeface="Calibri"/>
               </a:rPr>
-              <a:t>The 13 August 2026 financial proposal assumed an Odoo-only foundation for core banking. This architecture uses Apache Fineract for core banking so that Odoo remains the operating platform, rather than building that engine from scratch.
-The combined stack changes delivery composition. Effort and commercial terms will be confirmed under the engagement’s change-control process.</a:t>
+              <a:t>ACCESS
+TLS, OpenID Connect, multi-factor authentication, tenant and branch scope, licence enforcement on the API.</a:t>
+            </a:r>
+          </a:p>
+        </p:txBody>
+      </p:sp>
+      <p:sp>
+        <p:nvSpPr>
+          <p:cNvPr id="8" name="TextBox 7"/>
+          <p:cNvSpPr txBox="1"/>
+          <p:nvPr/>
+        </p:nvSpPr>
+        <p:spPr>
+          <a:xfrm>
+            <a:off x="4389120" y="2377440"/>
+            <a:ext cx="3474720" cy="3200400"/>
+          </a:xfrm>
+          <a:prstGeom prst="rect">
+            <a:avLst/>
+          </a:prstGeom>
+          <a:noFill/>
+        </p:spPr>
+        <p:txBody>
+          <a:bodyPr wrap="square">
+            <a:spAutoFit/>
+          </a:bodyPr>
+          <a:lstStyle/>
+          <a:p>
+            <a:pPr algn="l"/>
+            <a:r>
+              <a:rPr sz="1500" b="0">
+                <a:solidFill>
+                  <a:srgbClr val="F4F0E6"/>
+                </a:solidFill>
+                <a:latin typeface="Calibri"/>
+              </a:rPr>
+              <a:t>MONEY
+Core banking is the only ledger. Duplicate requests are not posted twice. Maker-checker. Core banking is not a public staff site.</a:t>
+            </a:r>
+          </a:p>
+        </p:txBody>
+      </p:sp>
+      <p:sp>
+        <p:nvSpPr>
+          <p:cNvPr id="9" name="TextBox 8"/>
+          <p:cNvSpPr txBox="1"/>
+          <p:nvPr/>
+        </p:nvSpPr>
+        <p:spPr>
+          <a:xfrm>
+            <a:off x="8138160" y="2377440"/>
+            <a:ext cx="3474720" cy="3200400"/>
+          </a:xfrm>
+          <a:prstGeom prst="rect">
+            <a:avLst/>
+          </a:prstGeom>
+          <a:noFill/>
+        </p:spPr>
+        <p:txBody>
+          <a:bodyPr wrap="square">
+            <a:spAutoFit/>
+          </a:bodyPr>
+          <a:lstStyle/>
+          <a:p>
+            <a:pPr algn="l"/>
+            <a:r>
+              <a:rPr sz="1500" b="0">
+                <a:solidFill>
+                  <a:srgbClr val="F4F0E6"/>
+                </a:solidFill>
+                <a:latin typeface="Calibri"/>
+              </a:rPr>
+              <a:t>OPERATIONS
+Encryption, NDPR, encrypted field store, audit, backup and restore, software bill of materials, penetration testing.</a:t>
             </a:r>
           </a:p>
         </p:txBody>
@@ -4558,6 +4524,625 @@
         </p:nvSpPr>
         <p:spPr>
           <a:xfrm>
+            <a:off x="640080" y="320040"/>
+            <a:ext cx="10972800" cy="320040"/>
+          </a:xfrm>
+          <a:prstGeom prst="rect">
+            <a:avLst/>
+          </a:prstGeom>
+          <a:noFill/>
+        </p:spPr>
+        <p:txBody>
+          <a:bodyPr wrap="square">
+            <a:spAutoFit/>
+          </a:bodyPr>
+          <a:lstStyle/>
+          <a:p>
+            <a:pPr algn="l"/>
+            <a:r>
+              <a:rPr sz="1200" b="1">
+                <a:solidFill>
+                  <a:srgbClr val="C4A056"/>
+                </a:solidFill>
+                <a:latin typeface="Calibri"/>
+              </a:rPr>
+              <a:t>SAME ENVIRONMENT</a:t>
+            </a:r>
+          </a:p>
+        </p:txBody>
+      </p:sp>
+      <p:sp>
+        <p:nvSpPr>
+          <p:cNvPr id="4" name="TextBox 3"/>
+          <p:cNvSpPr txBox="1"/>
+          <p:nvPr/>
+        </p:nvSpPr>
+        <p:spPr>
+          <a:xfrm>
+            <a:off x="640080" y="685800"/>
+            <a:ext cx="10972800" cy="1417320"/>
+          </a:xfrm>
+          <a:prstGeom prst="rect">
+            <a:avLst/>
+          </a:prstGeom>
+          <a:noFill/>
+        </p:spPr>
+        <p:txBody>
+          <a:bodyPr wrap="square">
+            <a:spAutoFit/>
+          </a:bodyPr>
+          <a:lstStyle/>
+          <a:p>
+            <a:pPr algn="l"/>
+            <a:r>
+              <a:rPr sz="3000" b="0">
+                <a:solidFill>
+                  <a:srgbClr val="F4F0E6"/>
+                </a:solidFill>
+                <a:latin typeface="Georgia"/>
+              </a:rPr>
+              <a:t>The operating platform and the
+integration service are neighbours.</a:t>
+            </a:r>
+          </a:p>
+        </p:txBody>
+      </p:sp>
+      <p:sp>
+        <p:nvSpPr>
+          <p:cNvPr id="5" name="TextBox 4"/>
+          <p:cNvSpPr txBox="1"/>
+          <p:nvPr/>
+        </p:nvSpPr>
+        <p:spPr>
+          <a:xfrm>
+            <a:off x="640080" y="6446520"/>
+            <a:ext cx="8229600" cy="228600"/>
+          </a:xfrm>
+          <a:prstGeom prst="rect">
+            <a:avLst/>
+          </a:prstGeom>
+          <a:noFill/>
+        </p:spPr>
+        <p:txBody>
+          <a:bodyPr wrap="square">
+            <a:spAutoFit/>
+          </a:bodyPr>
+          <a:lstStyle/>
+          <a:p>
+            <a:pPr algn="l"/>
+            <a:r>
+              <a:rPr sz="1100" b="0">
+                <a:solidFill>
+                  <a:srgbClr val="A8B3AA"/>
+                </a:solidFill>
+                <a:latin typeface="Calibri"/>
+              </a:rPr>
+              <a:t>Dexta Synergy Services  ·  Confidential</a:t>
+            </a:r>
+          </a:p>
+        </p:txBody>
+      </p:sp>
+      <p:sp>
+        <p:nvSpPr>
+          <p:cNvPr id="6" name="TextBox 5"/>
+          <p:cNvSpPr txBox="1"/>
+          <p:nvPr/>
+        </p:nvSpPr>
+        <p:spPr>
+          <a:xfrm>
+            <a:off x="10241280" y="6446520"/>
+            <a:ext cx="1463040" cy="228600"/>
+          </a:xfrm>
+          <a:prstGeom prst="rect">
+            <a:avLst/>
+          </a:prstGeom>
+          <a:noFill/>
+        </p:spPr>
+        <p:txBody>
+          <a:bodyPr wrap="square">
+            <a:spAutoFit/>
+          </a:bodyPr>
+          <a:lstStyle/>
+          <a:p>
+            <a:pPr algn="r"/>
+            <a:r>
+              <a:rPr sz="1100" b="0">
+                <a:solidFill>
+                  <a:srgbClr val="A8B3AA"/>
+                </a:solidFill>
+                <a:latin typeface="Calibri"/>
+              </a:rPr>
+              <a:t>14 / 16</a:t>
+            </a:r>
+          </a:p>
+        </p:txBody>
+      </p:sp>
+      <p:sp>
+        <p:nvSpPr>
+          <p:cNvPr id="7" name="TextBox 6"/>
+          <p:cNvSpPr txBox="1"/>
+          <p:nvPr/>
+        </p:nvSpPr>
+        <p:spPr>
+          <a:xfrm>
+            <a:off x="640080" y="2331720"/>
+            <a:ext cx="2560320" cy="2926080"/>
+          </a:xfrm>
+          <a:prstGeom prst="rect">
+            <a:avLst/>
+          </a:prstGeom>
+          <a:noFill/>
+        </p:spPr>
+        <p:txBody>
+          <a:bodyPr wrap="square">
+            <a:spAutoFit/>
+          </a:bodyPr>
+          <a:lstStyle/>
+          <a:p>
+            <a:pPr algn="l"/>
+            <a:r>
+              <a:rPr sz="1500" b="0">
+                <a:solidFill>
+                  <a:srgbClr val="F4F0E6"/>
+                </a:solidFill>
+                <a:latin typeface="Calibri"/>
+              </a:rPr>
+              <a:t>NGINX
+TLS at the edge</a:t>
+            </a:r>
+          </a:p>
+        </p:txBody>
+      </p:sp>
+      <p:sp>
+        <p:nvSpPr>
+          <p:cNvPr id="8" name="TextBox 7"/>
+          <p:cNvSpPr txBox="1"/>
+          <p:nvPr/>
+        </p:nvSpPr>
+        <p:spPr>
+          <a:xfrm>
+            <a:off x="3383280" y="2331720"/>
+            <a:ext cx="2560320" cy="2926080"/>
+          </a:xfrm>
+          <a:prstGeom prst="rect">
+            <a:avLst/>
+          </a:prstGeom>
+          <a:noFill/>
+        </p:spPr>
+        <p:txBody>
+          <a:bodyPr wrap="square">
+            <a:spAutoFit/>
+          </a:bodyPr>
+          <a:lstStyle/>
+          <a:p>
+            <a:pPr algn="l"/>
+            <a:r>
+              <a:rPr sz="1500" b="0">
+                <a:solidFill>
+                  <a:srgbClr val="F4F0E6"/>
+                </a:solidFill>
+                <a:latin typeface="Calibri"/>
+              </a:rPr>
+              <a:t>STAFF AND PORTAL
+Operating platform</a:t>
+            </a:r>
+          </a:p>
+        </p:txBody>
+      </p:sp>
+      <p:sp>
+        <p:nvSpPr>
+          <p:cNvPr id="9" name="TextBox 8"/>
+          <p:cNvSpPr txBox="1"/>
+          <p:nvPr/>
+        </p:nvSpPr>
+        <p:spPr>
+          <a:xfrm>
+            <a:off x="6126480" y="2331720"/>
+            <a:ext cx="2560320" cy="2926080"/>
+          </a:xfrm>
+          <a:prstGeom prst="rect">
+            <a:avLst/>
+          </a:prstGeom>
+          <a:noFill/>
+        </p:spPr>
+        <p:txBody>
+          <a:bodyPr wrap="square">
+            <a:spAutoFit/>
+          </a:bodyPr>
+          <a:lstStyle/>
+          <a:p>
+            <a:pPr algn="l"/>
+            <a:r>
+              <a:rPr sz="1500" b="0">
+                <a:solidFill>
+                  <a:srgbClr val="F4F0E6"/>
+                </a:solidFill>
+                <a:latin typeface="Calibri"/>
+              </a:rPr>
+              <a:t>APPS AND PARTNERS
+Integration service</a:t>
+            </a:r>
+          </a:p>
+        </p:txBody>
+      </p:sp>
+      <p:sp>
+        <p:nvSpPr>
+          <p:cNvPr id="10" name="TextBox 9"/>
+          <p:cNvSpPr txBox="1"/>
+          <p:nvPr/>
+        </p:nvSpPr>
+        <p:spPr>
+          <a:xfrm>
+            <a:off x="8869680" y="2331720"/>
+            <a:ext cx="2651760" cy="2926080"/>
+          </a:xfrm>
+          <a:prstGeom prst="rect">
+            <a:avLst/>
+          </a:prstGeom>
+          <a:noFill/>
+        </p:spPr>
+        <p:txBody>
+          <a:bodyPr wrap="square">
+            <a:spAutoFit/>
+          </a:bodyPr>
+          <a:lstStyle/>
+          <a:p>
+            <a:pPr algn="l"/>
+            <a:r>
+              <a:rPr sz="1500" b="0">
+                <a:solidFill>
+                  <a:srgbClr val="F4F0E6"/>
+                </a:solidFill>
+                <a:latin typeface="Calibri"/>
+              </a:rPr>
+              <a:t>CORE BANKING
+Internal only</a:t>
+            </a:r>
+          </a:p>
+        </p:txBody>
+      </p:sp>
+      <p:sp>
+        <p:nvSpPr>
+          <p:cNvPr id="11" name="TextBox 10"/>
+          <p:cNvSpPr txBox="1"/>
+          <p:nvPr/>
+        </p:nvSpPr>
+        <p:spPr>
+          <a:xfrm>
+            <a:off x="640080" y="5212080"/>
+            <a:ext cx="10972800" cy="914400"/>
+          </a:xfrm>
+          <a:prstGeom prst="rect">
+            <a:avLst/>
+          </a:prstGeom>
+          <a:noFill/>
+        </p:spPr>
+        <p:txBody>
+          <a:bodyPr wrap="square">
+            <a:spAutoFit/>
+          </a:bodyPr>
+          <a:lstStyle/>
+          <a:p>
+            <a:pPr algn="l"/>
+            <a:r>
+              <a:rPr sz="1600" b="0">
+                <a:solidFill>
+                  <a:srgbClr val="A8B3AA"/>
+                </a:solidFill>
+                <a:latin typeface="Calibri"/>
+              </a:rPr>
+              <a:t>Each component keeps its own database. They connect through the integration service.</a:t>
+            </a:r>
+          </a:p>
+        </p:txBody>
+      </p:sp>
+    </p:spTree>
+  </p:cSld>
+  <p:clrMapOvr>
+    <a:masterClrMapping/>
+  </p:clrMapOvr>
+</p:sld>
+</file>
+
+<file path=ppt/slides/slide15.xml><?xml version="1.0" encoding="utf-8"?>
+<p:sld xmlns:a="http://schemas.openxmlformats.org/drawingml/2006/main" xmlns:p="http://schemas.openxmlformats.org/presentationml/2006/main" xmlns:r="http://schemas.openxmlformats.org/officeDocument/2006/relationships">
+  <p:cSld>
+    <p:spTree>
+      <p:nvGrpSpPr>
+        <p:cNvPr id="1" name=""/>
+        <p:cNvGrpSpPr/>
+        <p:nvPr/>
+      </p:nvGrpSpPr>
+      <p:grpSpPr/>
+      <p:sp>
+        <p:nvSpPr>
+          <p:cNvPr id="2" name="Rectangle 1"/>
+          <p:cNvSpPr/>
+          <p:nvPr/>
+        </p:nvSpPr>
+        <p:spPr>
+          <a:xfrm>
+            <a:off x="0" y="0"/>
+            <a:ext cx="12191695" cy="6858000"/>
+          </a:xfrm>
+          <a:prstGeom prst="rect">
+            <a:avLst/>
+          </a:prstGeom>
+          <a:solidFill>
+            <a:srgbClr val="0B0F0D"/>
+          </a:solidFill>
+          <a:ln>
+            <a:noFill/>
+          </a:ln>
+        </p:spPr>
+        <p:style>
+          <a:lnRef idx="1">
+            <a:schemeClr val="accent1"/>
+          </a:lnRef>
+          <a:fillRef idx="3">
+            <a:schemeClr val="accent1"/>
+          </a:fillRef>
+          <a:effectRef idx="2">
+            <a:schemeClr val="accent1"/>
+          </a:effectRef>
+          <a:fontRef idx="minor">
+            <a:schemeClr val="lt1"/>
+          </a:fontRef>
+        </p:style>
+        <p:txBody>
+          <a:bodyPr rtlCol="0" anchor="ctr"/>
+          <a:lstStyle/>
+          <a:p>
+            <a:pPr algn="ctr"/>
+          </a:p>
+        </p:txBody>
+      </p:sp>
+      <p:sp>
+        <p:nvSpPr>
+          <p:cNvPr id="3" name="TextBox 2"/>
+          <p:cNvSpPr txBox="1"/>
+          <p:nvPr/>
+        </p:nvSpPr>
+        <p:spPr>
+          <a:xfrm>
+            <a:off x="640080" y="320040"/>
+            <a:ext cx="10972800" cy="320040"/>
+          </a:xfrm>
+          <a:prstGeom prst="rect">
+            <a:avLst/>
+          </a:prstGeom>
+          <a:noFill/>
+        </p:spPr>
+        <p:txBody>
+          <a:bodyPr wrap="square">
+            <a:spAutoFit/>
+          </a:bodyPr>
+          <a:lstStyle/>
+          <a:p>
+            <a:pPr algn="l"/>
+            <a:r>
+              <a:rPr sz="1200" b="1">
+                <a:solidFill>
+                  <a:srgbClr val="C4A056"/>
+                </a:solidFill>
+                <a:latin typeface="Calibri"/>
+              </a:rPr>
+              <a:t>FOUNDATION</a:t>
+            </a:r>
+          </a:p>
+        </p:txBody>
+      </p:sp>
+      <p:sp>
+        <p:nvSpPr>
+          <p:cNvPr id="4" name="TextBox 3"/>
+          <p:cNvSpPr txBox="1"/>
+          <p:nvPr/>
+        </p:nvSpPr>
+        <p:spPr>
+          <a:xfrm>
+            <a:off x="640080" y="685800"/>
+            <a:ext cx="10972800" cy="1417320"/>
+          </a:xfrm>
+          <a:prstGeom prst="rect">
+            <a:avLst/>
+          </a:prstGeom>
+          <a:noFill/>
+        </p:spPr>
+        <p:txBody>
+          <a:bodyPr wrap="square">
+            <a:spAutoFit/>
+          </a:bodyPr>
+          <a:lstStyle/>
+          <a:p>
+            <a:pPr algn="l"/>
+            <a:r>
+              <a:rPr sz="3000" b="0">
+                <a:solidFill>
+                  <a:srgbClr val="F4F0E6"/>
+                </a:solidFill>
+                <a:latin typeface="Georgia"/>
+              </a:rPr>
+              <a:t>Odoo remains the operating platform.
+Fineract provides core banking.</a:t>
+            </a:r>
+          </a:p>
+        </p:txBody>
+      </p:sp>
+      <p:sp>
+        <p:nvSpPr>
+          <p:cNvPr id="5" name="TextBox 4"/>
+          <p:cNvSpPr txBox="1"/>
+          <p:nvPr/>
+        </p:nvSpPr>
+        <p:spPr>
+          <a:xfrm>
+            <a:off x="640080" y="6446520"/>
+            <a:ext cx="8229600" cy="228600"/>
+          </a:xfrm>
+          <a:prstGeom prst="rect">
+            <a:avLst/>
+          </a:prstGeom>
+          <a:noFill/>
+        </p:spPr>
+        <p:txBody>
+          <a:bodyPr wrap="square">
+            <a:spAutoFit/>
+          </a:bodyPr>
+          <a:lstStyle/>
+          <a:p>
+            <a:pPr algn="l"/>
+            <a:r>
+              <a:rPr sz="1100" b="0">
+                <a:solidFill>
+                  <a:srgbClr val="A8B3AA"/>
+                </a:solidFill>
+                <a:latin typeface="Calibri"/>
+              </a:rPr>
+              <a:t>Dexta Synergy Services  ·  Confidential</a:t>
+            </a:r>
+          </a:p>
+        </p:txBody>
+      </p:sp>
+      <p:sp>
+        <p:nvSpPr>
+          <p:cNvPr id="6" name="TextBox 5"/>
+          <p:cNvSpPr txBox="1"/>
+          <p:nvPr/>
+        </p:nvSpPr>
+        <p:spPr>
+          <a:xfrm>
+            <a:off x="10241280" y="6446520"/>
+            <a:ext cx="1463040" cy="228600"/>
+          </a:xfrm>
+          <a:prstGeom prst="rect">
+            <a:avLst/>
+          </a:prstGeom>
+          <a:noFill/>
+        </p:spPr>
+        <p:txBody>
+          <a:bodyPr wrap="square">
+            <a:spAutoFit/>
+          </a:bodyPr>
+          <a:lstStyle/>
+          <a:p>
+            <a:pPr algn="r"/>
+            <a:r>
+              <a:rPr sz="1100" b="0">
+                <a:solidFill>
+                  <a:srgbClr val="A8B3AA"/>
+                </a:solidFill>
+                <a:latin typeface="Calibri"/>
+              </a:rPr>
+              <a:t>15 / 16</a:t>
+            </a:r>
+          </a:p>
+        </p:txBody>
+      </p:sp>
+      <p:sp>
+        <p:nvSpPr>
+          <p:cNvPr id="7" name="TextBox 6"/>
+          <p:cNvSpPr txBox="1"/>
+          <p:nvPr/>
+        </p:nvSpPr>
+        <p:spPr>
+          <a:xfrm>
+            <a:off x="640080" y="2377440"/>
+            <a:ext cx="10972800" cy="3291840"/>
+          </a:xfrm>
+          <a:prstGeom prst="rect">
+            <a:avLst/>
+          </a:prstGeom>
+          <a:noFill/>
+        </p:spPr>
+        <p:txBody>
+          <a:bodyPr wrap="square">
+            <a:spAutoFit/>
+          </a:bodyPr>
+          <a:lstStyle/>
+          <a:p>
+            <a:pPr algn="l"/>
+            <a:r>
+              <a:rPr sz="1800" b="0">
+                <a:solidFill>
+                  <a:srgbClr val="F4F0E6"/>
+                </a:solidFill>
+                <a:latin typeface="Calibri"/>
+              </a:rPr>
+              <a:t>The 13 August 2026 financial proposal assumed an Odoo-only foundation for core banking. This architecture uses Apache Fineract for core banking so that Odoo remains the operating platform, rather than building that engine from scratch.
+The combined stack changes delivery composition. Effort and commercial terms will be confirmed under the engagement’s change-control process.</a:t>
+            </a:r>
+          </a:p>
+        </p:txBody>
+      </p:sp>
+    </p:spTree>
+  </p:cSld>
+  <p:clrMapOvr>
+    <a:masterClrMapping/>
+  </p:clrMapOvr>
+</p:sld>
+</file>
+
+<file path=ppt/slides/slide16.xml><?xml version="1.0" encoding="utf-8"?>
+<p:sld xmlns:a="http://schemas.openxmlformats.org/drawingml/2006/main" xmlns:p="http://schemas.openxmlformats.org/presentationml/2006/main" xmlns:r="http://schemas.openxmlformats.org/officeDocument/2006/relationships">
+  <p:cSld>
+    <p:spTree>
+      <p:nvGrpSpPr>
+        <p:cNvPr id="1" name=""/>
+        <p:cNvGrpSpPr/>
+        <p:nvPr/>
+      </p:nvGrpSpPr>
+      <p:grpSpPr/>
+      <p:sp>
+        <p:nvSpPr>
+          <p:cNvPr id="2" name="Rectangle 1"/>
+          <p:cNvSpPr/>
+          <p:nvPr/>
+        </p:nvSpPr>
+        <p:spPr>
+          <a:xfrm>
+            <a:off x="0" y="0"/>
+            <a:ext cx="12191695" cy="6858000"/>
+          </a:xfrm>
+          <a:prstGeom prst="rect">
+            <a:avLst/>
+          </a:prstGeom>
+          <a:solidFill>
+            <a:srgbClr val="0B0F0D"/>
+          </a:solidFill>
+          <a:ln>
+            <a:noFill/>
+          </a:ln>
+        </p:spPr>
+        <p:style>
+          <a:lnRef idx="1">
+            <a:schemeClr val="accent1"/>
+          </a:lnRef>
+          <a:fillRef idx="3">
+            <a:schemeClr val="accent1"/>
+          </a:fillRef>
+          <a:effectRef idx="2">
+            <a:schemeClr val="accent1"/>
+          </a:effectRef>
+          <a:fontRef idx="minor">
+            <a:schemeClr val="lt1"/>
+          </a:fontRef>
+        </p:style>
+        <p:txBody>
+          <a:bodyPr rtlCol="0" anchor="ctr"/>
+          <a:lstStyle/>
+          <a:p>
+            <a:pPr algn="ctr"/>
+          </a:p>
+        </p:txBody>
+      </p:sp>
+      <p:sp>
+        <p:nvSpPr>
+          <p:cNvPr id="3" name="TextBox 2"/>
+          <p:cNvSpPr txBox="1"/>
+          <p:nvPr/>
+        </p:nvSpPr>
+        <p:spPr>
+          <a:xfrm>
             <a:off x="640080" y="365760"/>
             <a:ext cx="10972800" cy="320040"/>
           </a:xfrm>
@@ -4652,7 +5237,7 @@
                 </a:solidFill>
                 <a:latin typeface="Calibri"/>
               </a:rPr>
-              <a:t>Emeraid hosts EDFIP, onboards institutions, and licenses modules. Staff work in Odoo. Apache Fineract is the core banking engine. FastAPI, beside Odoo, is the path that moves money.</a:t>
+              <a:t>Emeraid hosts EDFIP, onboards institutions, and licenses modules. Staff and customers use the operating platform and the apps. Core banking holds the accounts. There is one customer, one set of accounts, and one ledger.</a:t>
             </a:r>
           </a:p>
         </p:txBody>
@@ -4722,7 +5307,7 @@
                 </a:solidFill>
                 <a:latin typeface="Calibri"/>
               </a:rPr>
-              <a:t>14 / 14</a:t>
+              <a:t>16 / 16</a:t>
             </a:r>
           </a:p>
         </p:txBody>
@@ -4924,7 +5509,7 @@
                 </a:solidFill>
                 <a:latin typeface="Calibri"/>
               </a:rPr>
-              <a:t>02 / 14</a:t>
+              <a:t>02 / 16</a:t>
             </a:r>
           </a:p>
         </p:txBody>
@@ -5270,7 +5855,7 @@
                 </a:solidFill>
                 <a:latin typeface="Calibri"/>
               </a:rPr>
-              <a:t>03 / 14</a:t>
+              <a:t>03 / 16</a:t>
             </a:r>
           </a:p>
         </p:txBody>
@@ -5654,7 +6239,7 @@
                 </a:solidFill>
                 <a:latin typeface="Calibri"/>
               </a:rPr>
-              <a:t>04 / 14</a:t>
+              <a:t>04 / 16</a:t>
             </a:r>
           </a:p>
         </p:txBody>
@@ -5929,8 +6514,8 @@
                 </a:solidFill>
                 <a:latin typeface="Georgia"/>
               </a:rPr>
-              <a:t>Staff open Odoo.
-Channels open the API.</a:t>
+              <a:t>Staff open the operating platform.
+Customers open the app or portal.</a:t>
             </a:r>
           </a:p>
         </p:txBody>
@@ -6000,7 +6585,7 @@
                 </a:solidFill>
                 <a:latin typeface="Calibri"/>
               </a:rPr>
-              <a:t>05 / 14</a:t>
+              <a:t>05 / 16</a:t>
             </a:r>
           </a:p>
         </p:txBody>
@@ -6035,8 +6620,8 @@
                 </a:solidFill>
                 <a:latin typeface="Calibri"/>
               </a:rPr>
-              <a:t>ODOO
-Institution staff, Emeraid Super Administrators, customer web portal.</a:t>
+              <a:t>STAFF AND ADMINISTRATORS
+Institution staff and Emeraid Super Administrators work on the operating platform. The customer web portal is here too.</a:t>
             </a:r>
           </a:p>
         </p:txBody>
@@ -6071,8 +6656,8 @@
                 </a:solidFill>
                 <a:latin typeface="Calibri"/>
               </a:rPr>
-              <a:t>FASTAPI  ·  /api
-Flutter, USSD, payment providers, OEM callbacks, partner integrations.</a:t>
+              <a:t>APPS AND CHANNELS
+Field app, customer app, USSD, payment providers, and OEM callbacks use the integration service.</a:t>
             </a:r>
           </a:p>
         </p:txBody>
@@ -6107,7 +6692,7 @@
                 </a:solidFill>
                 <a:latin typeface="Calibri"/>
               </a:rPr>
-              <a:t>Fineract is not a public staff website. When a teller posts a repayment in Odoo, the Odoo server calls FastAPI, which posts to Fineract.</a:t>
+              <a:t>Core banking is not a public staff website. Money is confirmed there; people work on the operating platform and the apps.</a:t>
             </a:r>
           </a:p>
         </p:txBody>
@@ -6239,7 +6824,7 @@
                 <a:latin typeface="Georgia"/>
               </a:rPr>
               <a:t>Every naira is posted once,
-in Fineract.</a:t>
+in core banking.</a:t>
             </a:r>
           </a:p>
         </p:txBody>
@@ -6309,7 +6894,7 @@
                 </a:solidFill>
                 <a:latin typeface="Calibri"/>
               </a:rPr>
-              <a:t>06 / 14</a:t>
+              <a:t>06 / 16</a:t>
             </a:r>
           </a:p>
         </p:txBody>
@@ -6345,7 +6930,7 @@
                 <a:latin typeface="Calibri"/>
               </a:rPr>
               <a:t>INSTRUCTION
-Teller, field app, USSD, or payment webhook</a:t>
+Teller, officer, field app, customer app, or payment</a:t>
             </a:r>
           </a:p>
         </p:txBody>
@@ -6380,8 +6965,8 @@
                 </a:solidFill>
                 <a:latin typeface="Calibri"/>
               </a:rPr>
-              <a:t>FASTAPI
-Identity, licence, branch, idempotency key</a:t>
+              <a:t>INTEGRATION
+Who is acting, licence, and branch</a:t>
             </a:r>
           </a:p>
         </p:txBody>
@@ -6416,7 +7001,7 @@
                 </a:solidFill>
                 <a:latin typeface="Calibri"/>
               </a:rPr>
-              <a:t>FINERACT
+              <a:t>CORE BANKING
 Posts the transaction and updates the ledger</a:t>
             </a:r>
           </a:p>
@@ -6452,8 +7037,8 @@
                 </a:solidFill>
                 <a:latin typeface="Calibri"/>
               </a:rPr>
-              <a:t>ODOO
-Shows confirmed status and issues the receipt</a:t>
+              <a:t>OPERATING PLATFORM
+Shows the receipt to staff and, where appropriate, to the customer</a:t>
             </a:r>
           </a:p>
         </p:txBody>
@@ -6488,7 +7073,7 @@
                 </a:solidFill>
                 <a:latin typeface="Calibri"/>
               </a:rPr>
-              <a:t>If the network fails after posting, the same key is retried. A second posting is not created.</a:t>
+              <a:t>If the network fails after posting, the same instruction is retried. A second posting is not created.</a:t>
             </a:r>
           </a:p>
         </p:txBody>
@@ -6619,7 +7204,7 @@
                 </a:solidFill>
                 <a:latin typeface="Georgia"/>
               </a:rPr>
-              <a:t>From licence to a live tenant.</a:t>
+              <a:t>From licence to a live institution.</a:t>
             </a:r>
           </a:p>
         </p:txBody>
@@ -6689,7 +7274,7 @@
                 </a:solidFill>
                 <a:latin typeface="Calibri"/>
               </a:rPr>
-              <a:t>07 / 14</a:t>
+              <a:t>07 / 16</a:t>
             </a:r>
           </a:p>
         </p:txBody>
@@ -6725,10 +7310,9 @@
                 <a:latin typeface="Calibri"/>
               </a:rPr>
               <a:t>1.  Super Administrator creates the institution, branding, and module pack.
-2.  Head Office and branches are recorded.
-3.  The Institution Administrator is invited.
-4.  FastAPI creates the Fineract tenant and an office for each branch.
-5.  Institution Administrator assigns staff to roles and branches. Staff log into Odoo.</a:t>
+2.  Head Office and branches are recorded. The institution’s administrator is invited.
+3.  Core banking is prepared for that institution, with a matching office for each branch.
+4.  Staff are given roles and branches. They sign in and see only their institution and those branches.</a:t>
             </a:r>
           </a:p>
         </p:txBody>
@@ -6859,8 +7443,8 @@
                 </a:solidFill>
                 <a:latin typeface="Georgia"/>
               </a:rPr>
-              <a:t>Configured in Odoo.
-Enforced for money in Fineract.</a:t>
+              <a:t>Staff see their branch.
+Money can only post there.</a:t>
             </a:r>
           </a:p>
         </p:txBody>
@@ -6930,7 +7514,7 @@
                 </a:solidFill>
                 <a:latin typeface="Calibri"/>
               </a:rPr>
-              <a:t>08 / 14</a:t>
+              <a:t>08 / 16</a:t>
             </a:r>
           </a:p>
         </p:txBody>
@@ -6965,8 +7549,8 @@
                 </a:solidFill>
                 <a:latin typeface="Calibri"/>
               </a:rPr>
-              <a:t>ODOO
-A Garki officer does not see Wuse records.</a:t>
+              <a:t>OPERATING PLATFORM
+A Garki officer does not see Wuse customers.</a:t>
             </a:r>
           </a:p>
         </p:txBody>
@@ -7001,7 +7585,7 @@
                 </a:solidFill>
                 <a:latin typeface="Calibri"/>
               </a:rPr>
-              <a:t>FASTAPI
+              <a:t>INTEGRATION SERVICE
 A request for another branch is refused.</a:t>
             </a:r>
           </a:p>
@@ -7037,8 +7621,8 @@
                 </a:solidFill>
                 <a:latin typeface="Calibri"/>
               </a:rPr>
-              <a:t>FINERACT
-Postings can only land in the mapped office.</a:t>
+              <a:t>CORE BANKING
+Postings can only land in the matching branch.</a:t>
             </a:r>
           </a:p>
         </p:txBody>
@@ -7073,7 +7657,7 @@
                 </a:solidFill>
                 <a:latin typeface="Calibri"/>
               </a:rPr>
-              <a:t>Institution finance may see all branches of their own institution. They cannot see another tenant.</a:t>
+              <a:t>Institution finance may see all branches of their own institution. They cannot see another institution.</a:t>
             </a:r>
           </a:p>
         </p:txBody>
@@ -7169,7 +7753,7 @@
                 </a:solidFill>
                 <a:latin typeface="Calibri"/>
               </a:rPr>
-              <a:t>CONTROL PLANE</a:t>
+              <a:t>CUSTOMERS</a:t>
             </a:r>
           </a:p>
         </p:txBody>
@@ -7204,8 +7788,8 @@
                 </a:solidFill>
                 <a:latin typeface="Georgia"/>
               </a:rPr>
-              <a:t>System Administration is how
-Emeraid operates the SaaS.</a:t>
+              <a:t>A customer belongs to the institution,
+a branch, and an officer.</a:t>
             </a:r>
           </a:p>
         </p:txBody>
@@ -7275,7 +7859,7 @@
                 </a:solidFill>
                 <a:latin typeface="Calibri"/>
               </a:rPr>
-              <a:t>09 / 14</a:t>
+              <a:t>09 / 16</a:t>
             </a:r>
           </a:p>
         </p:txBody>
@@ -7288,8 +7872,8 @@
         </p:nvSpPr>
         <p:spPr>
           <a:xfrm>
-            <a:off x="640080" y="2468880"/>
-            <a:ext cx="5303520" cy="2926080"/>
+            <a:off x="640080" y="2286000"/>
+            <a:ext cx="10972800" cy="3840480"/>
           </a:xfrm>
           <a:prstGeom prst="rect">
             <a:avLst/>
@@ -7310,44 +7894,11 @@
                 </a:solidFill>
                 <a:latin typeface="Calibri"/>
               </a:rPr>
-              <a:t>EMERAID SUPER ADMINISTRATOR
-Institutions, licences, packs, platform connectors, core-banking provisioning. Multi-factor authentication and a full audit trail.</a:t>
-            </a:r>
-          </a:p>
-        </p:txBody>
-      </p:sp>
-      <p:sp>
-        <p:nvSpPr>
-          <p:cNvPr id="8" name="TextBox 7"/>
-          <p:cNvSpPr txBox="1"/>
-          <p:nvPr/>
-        </p:nvSpPr>
-        <p:spPr>
-          <a:xfrm>
-            <a:off x="6400800" y="2468880"/>
-            <a:ext cx="5120640" cy="2926080"/>
-          </a:xfrm>
-          <a:prstGeom prst="rect">
-            <a:avLst/>
-          </a:prstGeom>
-          <a:noFill/>
-        </p:spPr>
-        <p:txBody>
-          <a:bodyPr wrap="square">
-            <a:spAutoFit/>
-          </a:bodyPr>
-          <a:lstStyle/>
-          <a:p>
-            <a:pPr algn="l"/>
-            <a:r>
-              <a:rPr sz="1600" b="0">
-                <a:solidFill>
-                  <a:srgbClr val="F4F0E6"/>
-                </a:solidFill>
-                <a:latin typeface="Calibri"/>
-              </a:rPr>
-              <a:t>INSTITUTION ADMINISTRATOR
-Their branches, staff, and local branding. They cannot see another institution or Emeraid’s platform credentials.</a:t>
+              <a:t>1.  Record — opened at a branch and assigned to an account officer.
+2.  KYC — approved on the operating platform.
+3.  Core banking — the same person is opened at that branch.
+4.  Account — savings or loan is created in core banking.
+The customer application and portal show only that person’s accounts.</a:t>
             </a:r>
           </a:p>
         </p:txBody>

</xml_diff>

<commit_message>
Restore Alison’s IPO flows and build SaaS, System Administration, and packs on top.
Removes the August-proposal recap from the architecture pack. Keeps Input–Process–Output lists, ownership matrix, and consistency model, and adds the operating-model sections.

Co-authored-by: Eyuren Hanson <hansoneyuren@gmail.com>
</commit_message>
<xml_diff>
--- a/edfip-screening/architecture/EDFIP_Architecture_Dexta.pptx
+++ b/edfip-screening/architecture/EDFIP_Architecture_Dexta.pptx
@@ -4927,7 +4927,7 @@
                 </a:solidFill>
                 <a:latin typeface="Calibri"/>
               </a:rPr>
-              <a:t>FOUNDATION</a:t>
+              <a:t>END-TO-END FLOW</a:t>
             </a:r>
           </a:p>
         </p:txBody>
@@ -4962,8 +4962,8 @@
                 </a:solidFill>
                 <a:latin typeface="Georgia"/>
               </a:rPr>
-              <a:t>Odoo remains the operating platform.
-Fineract provides core banking.</a:t>
+              <a:t>Customer onboarding —
+input, process, output.</a:t>
             </a:r>
           </a:p>
         </p:txBody>
@@ -5046,30 +5046,31 @@
         </p:nvSpPr>
         <p:spPr>
           <a:xfrm>
-            <a:off x="640080" y="2377440"/>
-            <a:ext cx="10972800" cy="3291840"/>
-          </a:xfrm>
-          <a:prstGeom prst="rect">
-            <a:avLst/>
-          </a:prstGeom>
-          <a:noFill/>
-        </p:spPr>
-        <p:txBody>
-          <a:bodyPr wrap="square">
-            <a:spAutoFit/>
-          </a:bodyPr>
-          <a:lstStyle/>
-          <a:p>
-            <a:pPr algn="l"/>
-            <a:r>
-              <a:rPr sz="1800" b="0">
+            <a:off x="640080" y="2286000"/>
+            <a:ext cx="10972800" cy="3840480"/>
+          </a:xfrm>
+          <a:prstGeom prst="rect">
+            <a:avLst/>
+          </a:prstGeom>
+          <a:noFill/>
+        </p:spPr>
+        <p:txBody>
+          <a:bodyPr wrap="square">
+            <a:spAutoFit/>
+          </a:bodyPr>
+          <a:lstStyle/>
+          <a:p>
+            <a:pPr algn="l"/>
+            <a:r>
+              <a:rPr sz="1600" b="0">
                 <a:solidFill>
                   <a:srgbClr val="F4F0E6"/>
                 </a:solidFill>
                 <a:latin typeface="Calibri"/>
               </a:rPr>
-              <a:t>The 13 August 2026 financial proposal assumed an Odoo-only foundation for core banking. This architecture uses Apache Fineract for core banking so that Odoo remains the operating platform, rather than building that engine from scratch.
-The combined stack changes delivery composition. Effort and commercial terms will be confirmed under the engagement’s change-control process.</a:t>
+              <a:t>Input.  Customer details, KYC, consent, institution, branch, account officer.
+Process.  Odoo completes KYC. The integration layer assigns one customer ID. Fineract opens the financial client at that branch.
+Output.  Approved customer, linked IDs, KYC status, branch and officer. The customer app shows only that person’s accounts.</a:t>
             </a:r>
           </a:p>
         </p:txBody>

</xml_diff>

<commit_message>
Align flow slides with the written architecture: people enter, money path, IPO examples.
Expands the end-to-end slide to customer, loan and repayment in Input–Process–Output form.

Co-authored-by: Eyuren Hanson <hansoneyuren@gmail.com>
</commit_message>
<xml_diff>
--- a/edfip-screening/architecture/EDFIP_Architecture_Dexta.pptx
+++ b/edfip-screening/architecture/EDFIP_Architecture_Dexta.pptx
@@ -4927,7 +4927,7 @@
                 </a:solidFill>
                 <a:latin typeface="Calibri"/>
               </a:rPr>
-              <a:t>END-TO-END FLOW</a:t>
+              <a:t>END-TO-END FLOWS</a:t>
             </a:r>
           </a:p>
         </p:txBody>
@@ -4962,8 +4962,8 @@
                 </a:solidFill>
                 <a:latin typeface="Georgia"/>
               </a:rPr>
-              <a:t>Customer onboarding —
-input, process, output.</a:t>
+              <a:t>Input, process, output —
+the same form for every process.</a:t>
             </a:r>
           </a:p>
         </p:txBody>
@@ -5047,30 +5047,142 @@
         <p:spPr>
           <a:xfrm>
             <a:off x="640080" y="2286000"/>
-            <a:ext cx="10972800" cy="3840480"/>
-          </a:xfrm>
-          <a:prstGeom prst="rect">
-            <a:avLst/>
-          </a:prstGeom>
-          <a:noFill/>
-        </p:spPr>
-        <p:txBody>
-          <a:bodyPr wrap="square">
-            <a:spAutoFit/>
-          </a:bodyPr>
-          <a:lstStyle/>
-          <a:p>
-            <a:pPr algn="l"/>
-            <a:r>
-              <a:rPr sz="1600" b="0">
+            <a:ext cx="3474720" cy="3291840"/>
+          </a:xfrm>
+          <a:prstGeom prst="rect">
+            <a:avLst/>
+          </a:prstGeom>
+          <a:noFill/>
+        </p:spPr>
+        <p:txBody>
+          <a:bodyPr wrap="square">
+            <a:spAutoFit/>
+          </a:bodyPr>
+          <a:lstStyle/>
+          <a:p>
+            <a:pPr algn="l"/>
+            <a:r>
+              <a:rPr sz="1400" b="0">
                 <a:solidFill>
                   <a:srgbClr val="F4F0E6"/>
                 </a:solidFill>
                 <a:latin typeface="Calibri"/>
               </a:rPr>
-              <a:t>Input.  Customer details, KYC, consent, institution, branch, account officer.
-Process.  Odoo completes KYC. The integration layer assigns one customer ID. Fineract opens the financial client at that branch.
-Output.  Approved customer, linked IDs, KYC status, branch and officer. The customer app shows only that person’s accounts.</a:t>
+              <a:t>CUSTOMER
+In: details, KYC, branch, officer.
+Then: Odoo KYC; one ID; Fineract client at that branch.
+Out: approved customer, linked IDs.</a:t>
+            </a:r>
+          </a:p>
+        </p:txBody>
+      </p:sp>
+      <p:sp>
+        <p:nvSpPr>
+          <p:cNvPr id="8" name="TextBox 7"/>
+          <p:cNvSpPr txBox="1"/>
+          <p:nvPr/>
+        </p:nvSpPr>
+        <p:spPr>
+          <a:xfrm>
+            <a:off x="4389120" y="2286000"/>
+            <a:ext cx="3474720" cy="3291840"/>
+          </a:xfrm>
+          <a:prstGeom prst="rect">
+            <a:avLst/>
+          </a:prstGeom>
+          <a:noFill/>
+        </p:spPr>
+        <p:txBody>
+          <a:bodyPr wrap="square">
+            <a:spAutoFit/>
+          </a:bodyPr>
+          <a:lstStyle/>
+          <a:p>
+            <a:pPr algn="l"/>
+            <a:r>
+              <a:rPr sz="1400" b="0">
+                <a:solidFill>
+                  <a:srgbClr val="F4F0E6"/>
+                </a:solidFill>
+                <a:latin typeface="Calibri"/>
+              </a:rPr>
+              <a:t>LOAN
+In: application, product, amount, tenor.
+Then: Odoo appraisal; Fineract loan at that branch.
+Out: account, schedule, audit trail.</a:t>
+            </a:r>
+          </a:p>
+        </p:txBody>
+      </p:sp>
+      <p:sp>
+        <p:nvSpPr>
+          <p:cNvPr id="9" name="TextBox 8"/>
+          <p:cNvSpPr txBox="1"/>
+          <p:nvPr/>
+        </p:nvSpPr>
+        <p:spPr>
+          <a:xfrm>
+            <a:off x="8138160" y="2286000"/>
+            <a:ext cx="3474720" cy="3291840"/>
+          </a:xfrm>
+          <a:prstGeom prst="rect">
+            <a:avLst/>
+          </a:prstGeom>
+          <a:noFill/>
+        </p:spPr>
+        <p:txBody>
+          <a:bodyPr wrap="square">
+            <a:spAutoFit/>
+          </a:bodyPr>
+          <a:lstStyle/>
+          <a:p>
+            <a:pPr algn="l"/>
+            <a:r>
+              <a:rPr sz="1400" b="0">
+                <a:solidFill>
+                  <a:srgbClr val="F4F0E6"/>
+                </a:solidFill>
+                <a:latin typeface="Calibri"/>
+              </a:rPr>
+              <a:t>REPAYMENT
+In: amount, account, channel.
+Then: one posting in Fineract; Odoo receipt.
+Out: confirmed balance, no duplicate.</a:t>
+            </a:r>
+          </a:p>
+        </p:txBody>
+      </p:sp>
+      <p:sp>
+        <p:nvSpPr>
+          <p:cNvPr id="10" name="TextBox 9"/>
+          <p:cNvSpPr txBox="1"/>
+          <p:nvPr/>
+        </p:nvSpPr>
+        <p:spPr>
+          <a:xfrm>
+            <a:off x="640080" y="5623560"/>
+            <a:ext cx="10972800" cy="548640"/>
+          </a:xfrm>
+          <a:prstGeom prst="rect">
+            <a:avLst/>
+          </a:prstGeom>
+          <a:noFill/>
+        </p:spPr>
+        <p:txBody>
+          <a:bodyPr wrap="square">
+            <a:spAutoFit/>
+          </a:bodyPr>
+          <a:lstStyle/>
+          <a:p>
+            <a:pPr algn="l"/>
+            <a:r>
+              <a:rPr sz="1400" b="0">
+                <a:solidFill>
+                  <a:srgbClr val="A8B3AA"/>
+                </a:solidFill>
+                <a:latin typeface="Calibri"/>
+              </a:rPr>
+              <a:t>PayGo, VSLA share-out and offline collections use the same pattern.</a:t>
             </a:r>
           </a:p>
         </p:txBody>

</xml_diff>